<commit_message>
Add Indonesian version of the project deck
build-project-deck.js now builds English (default) or Bahasa Indonesia
(`node build-project-deck.js id`) from one source, including speaker
notes and a localized landing page screenshot. Also fixes two labels
that wrapped in both languages.

Co-Authored-By: Claude Opus 5.5 <noreply@anthropic.com>
</commit_message>
<xml_diff>
--- a/flyer/komunitas-project-deck.pptx
+++ b/flyer/komunitas-project-deck.pptx
@@ -3040,7 +3040,7 @@
         <p:spPr>
           <a:xfrm>
             <a:off x="731520" y="3977640"/>
-            <a:ext cx="10058400" cy="548640"/>
+            <a:ext cx="10515600" cy="548640"/>
           </a:xfrm>
           <a:prstGeom prst="rect">
             <a:avLst/>
@@ -3079,7 +3079,7 @@
         <p:spPr>
           <a:xfrm>
             <a:off x="731520" y="4572000"/>
-            <a:ext cx="9601200" cy="457200"/>
+            <a:ext cx="10058400" cy="457200"/>
           </a:xfrm>
           <a:prstGeom prst="rect">
             <a:avLst/>
@@ -4073,7 +4073,7 @@
         <p:spPr>
           <a:xfrm>
             <a:off x="640080" y="5029200"/>
-            <a:ext cx="6400800" cy="320040"/>
+            <a:ext cx="8229600" cy="320040"/>
           </a:xfrm>
           <a:prstGeom prst="rect">
             <a:avLst/>
@@ -4613,7 +4613,7 @@
         <p:spPr>
           <a:xfrm>
             <a:off x="8092440" y="5440680"/>
-            <a:ext cx="1463040" cy="411480"/>
+            <a:ext cx="1828800" cy="411480"/>
           </a:xfrm>
           <a:prstGeom prst="rect">
             <a:avLst/>
@@ -9347,7 +9347,7 @@
         <p:spPr>
           <a:xfrm>
             <a:off x="914400" y="2852928"/>
-            <a:ext cx="1508760" cy="365760"/>
+            <a:ext cx="1554480" cy="365760"/>
           </a:xfrm>
           <a:prstGeom prst="rect">
             <a:avLst/>
@@ -9529,7 +9529,7 @@
         <p:spPr>
           <a:xfrm>
             <a:off x="3154680" y="2852928"/>
-            <a:ext cx="1508760" cy="365760"/>
+            <a:ext cx="1554480" cy="365760"/>
           </a:xfrm>
           <a:prstGeom prst="rect">
             <a:avLst/>
@@ -9711,7 +9711,7 @@
         <p:spPr>
           <a:xfrm>
             <a:off x="5394960" y="2852928"/>
-            <a:ext cx="1508760" cy="365760"/>
+            <a:ext cx="1554480" cy="365760"/>
           </a:xfrm>
           <a:prstGeom prst="rect">
             <a:avLst/>
@@ -9893,7 +9893,7 @@
         <p:spPr>
           <a:xfrm>
             <a:off x="7635240" y="2852928"/>
-            <a:ext cx="1508760" cy="365760"/>
+            <a:ext cx="1554480" cy="365760"/>
           </a:xfrm>
           <a:prstGeom prst="rect">
             <a:avLst/>
@@ -10075,7 +10075,7 @@
         <p:spPr>
           <a:xfrm>
             <a:off x="9875520" y="2852928"/>
-            <a:ext cx="1508760" cy="365760"/>
+            <a:ext cx="1554480" cy="365760"/>
           </a:xfrm>
           <a:prstGeom prst="rect">
             <a:avLst/>
@@ -11413,7 +11413,7 @@
                 <a:ea typeface="Arial" pitchFamily="34" charset="-122"/>
                 <a:cs typeface="Arial" pitchFamily="34" charset="-120"/>
               </a:rPr>
-              <a:t>Cookie + local storage</a:t>
+              <a:t>Cookie &amp; browser</a:t>
             </a:r>
             <a:endParaRPr lang="en-US" sz="1200" dirty="0"/>
           </a:p>
@@ -13654,7 +13654,7 @@
         <p:spPr>
           <a:xfrm>
             <a:off x="1600200" y="1810512"/>
-            <a:ext cx="4297680" cy="365760"/>
+            <a:ext cx="4389120" cy="365760"/>
           </a:xfrm>
           <a:prstGeom prst="rect">
             <a:avLst/>
@@ -13693,7 +13693,7 @@
         <p:spPr>
           <a:xfrm>
             <a:off x="1600200" y="2194560"/>
-            <a:ext cx="4297680" cy="731520"/>
+            <a:ext cx="4389120" cy="731520"/>
           </a:xfrm>
           <a:prstGeom prst="rect">
             <a:avLst/>
@@ -13778,7 +13778,7 @@
         <p:spPr>
           <a:xfrm>
             <a:off x="7178040" y="1810512"/>
-            <a:ext cx="4297680" cy="365760"/>
+            <a:ext cx="4389120" cy="365760"/>
           </a:xfrm>
           <a:prstGeom prst="rect">
             <a:avLst/>
@@ -13817,7 +13817,7 @@
         <p:spPr>
           <a:xfrm>
             <a:off x="7178040" y="2194560"/>
-            <a:ext cx="4297680" cy="731520"/>
+            <a:ext cx="4389120" cy="731520"/>
           </a:xfrm>
           <a:prstGeom prst="rect">
             <a:avLst/>
@@ -13902,7 +13902,7 @@
         <p:spPr>
           <a:xfrm>
             <a:off x="1600200" y="3182112"/>
-            <a:ext cx="4297680" cy="365760"/>
+            <a:ext cx="4389120" cy="365760"/>
           </a:xfrm>
           <a:prstGeom prst="rect">
             <a:avLst/>
@@ -13941,7 +13941,7 @@
         <p:spPr>
           <a:xfrm>
             <a:off x="1600200" y="3566160"/>
-            <a:ext cx="4297680" cy="731520"/>
+            <a:ext cx="4389120" cy="731520"/>
           </a:xfrm>
           <a:prstGeom prst="rect">
             <a:avLst/>
@@ -14026,7 +14026,7 @@
         <p:spPr>
           <a:xfrm>
             <a:off x="7178040" y="3182112"/>
-            <a:ext cx="4297680" cy="365760"/>
+            <a:ext cx="4389120" cy="365760"/>
           </a:xfrm>
           <a:prstGeom prst="rect">
             <a:avLst/>
@@ -14065,7 +14065,7 @@
         <p:spPr>
           <a:xfrm>
             <a:off x="7178040" y="3566160"/>
-            <a:ext cx="4297680" cy="731520"/>
+            <a:ext cx="4389120" cy="731520"/>
           </a:xfrm>
           <a:prstGeom prst="rect">
             <a:avLst/>
@@ -14150,7 +14150,7 @@
         <p:spPr>
           <a:xfrm>
             <a:off x="1600200" y="4553712"/>
-            <a:ext cx="4297680" cy="365760"/>
+            <a:ext cx="4389120" cy="365760"/>
           </a:xfrm>
           <a:prstGeom prst="rect">
             <a:avLst/>
@@ -14189,7 +14189,7 @@
         <p:spPr>
           <a:xfrm>
             <a:off x="1600200" y="4937760"/>
-            <a:ext cx="4297680" cy="731520"/>
+            <a:ext cx="4389120" cy="731520"/>
           </a:xfrm>
           <a:prstGeom prst="rect">
             <a:avLst/>
@@ -14274,7 +14274,7 @@
         <p:spPr>
           <a:xfrm>
             <a:off x="7178040" y="4553712"/>
-            <a:ext cx="4297680" cy="365760"/>
+            <a:ext cx="4389120" cy="365760"/>
           </a:xfrm>
           <a:prstGeom prst="rect">
             <a:avLst/>
@@ -14313,7 +14313,7 @@
         <p:spPr>
           <a:xfrm>
             <a:off x="7178040" y="4937760"/>
-            <a:ext cx="4297680" cy="731520"/>
+            <a:ext cx="4389120" cy="731520"/>
           </a:xfrm>
           <a:prstGeom prst="rect">
             <a:avLst/>
@@ -19346,7 +19346,7 @@
         <p:spPr>
           <a:xfrm>
             <a:off x="1600200" y="1810512"/>
-            <a:ext cx="4754880" cy="365760"/>
+            <a:ext cx="4846320" cy="365760"/>
           </a:xfrm>
           <a:prstGeom prst="rect">
             <a:avLst/>
@@ -19385,7 +19385,7 @@
         <p:spPr>
           <a:xfrm>
             <a:off x="1600200" y="2212848"/>
-            <a:ext cx="4754880" cy="868680"/>
+            <a:ext cx="4846320" cy="868680"/>
           </a:xfrm>
           <a:prstGeom prst="rect">
             <a:avLst/>
@@ -19470,7 +19470,7 @@
         <p:spPr>
           <a:xfrm>
             <a:off x="1600200" y="3182112"/>
-            <a:ext cx="4754880" cy="365760"/>
+            <a:ext cx="4846320" cy="365760"/>
           </a:xfrm>
           <a:prstGeom prst="rect">
             <a:avLst/>
@@ -19509,7 +19509,7 @@
         <p:spPr>
           <a:xfrm>
             <a:off x="1600200" y="3584448"/>
-            <a:ext cx="4754880" cy="868680"/>
+            <a:ext cx="4846320" cy="868680"/>
           </a:xfrm>
           <a:prstGeom prst="rect">
             <a:avLst/>
@@ -19594,7 +19594,7 @@
         <p:spPr>
           <a:xfrm>
             <a:off x="1600200" y="4553712"/>
-            <a:ext cx="4754880" cy="365760"/>
+            <a:ext cx="4846320" cy="365760"/>
           </a:xfrm>
           <a:prstGeom prst="rect">
             <a:avLst/>
@@ -19633,7 +19633,7 @@
         <p:spPr>
           <a:xfrm>
             <a:off x="1600200" y="4956048"/>
-            <a:ext cx="4754880" cy="868680"/>
+            <a:ext cx="4846320" cy="868680"/>
           </a:xfrm>
           <a:prstGeom prst="rect">
             <a:avLst/>
@@ -20117,8 +20117,8 @@
         </p:nvSpPr>
         <p:spPr>
           <a:xfrm>
-            <a:off x="868680" y="3200400"/>
-            <a:ext cx="1554480" cy="457200"/>
+            <a:off x="868680" y="3108960"/>
+            <a:ext cx="1554480" cy="548640"/>
           </a:xfrm>
           <a:prstGeom prst="rect">
             <a:avLst/>
@@ -20134,7 +20134,7 @@
               <a:buNone/>
             </a:pPr>
             <a:r>
-              <a:rPr lang="en-US" sz="1800" b="1" dirty="0">
+              <a:rPr lang="en-US" sz="1700" b="1" dirty="0">
                 <a:solidFill>
                   <a:srgbClr val="292524"/>
                 </a:solidFill>
@@ -20144,7 +20144,7 @@
               </a:rPr>
               <a:t>Nearby first</a:t>
             </a:r>
-            <a:endParaRPr lang="en-US" sz="1800" dirty="0"/>
+            <a:endParaRPr lang="en-US" sz="1700" dirty="0"/>
           </a:p>
         </p:txBody>
       </p:sp>
@@ -20173,7 +20173,7 @@
               <a:buNone/>
             </a:pPr>
             <a:r>
-              <a:rPr lang="en-US" sz="1400" dirty="0">
+              <a:rPr lang="en-US" sz="1350" dirty="0">
                 <a:solidFill>
                   <a:srgbClr val="78716C"/>
                 </a:solidFill>
@@ -20183,7 +20183,7 @@
               </a:rPr>
               <a:t>The dashboard shows open activities within 20 km of you, matched to your hobbies.</a:t>
             </a:r>
-            <a:endParaRPr lang="en-US" sz="1400" dirty="0"/>
+            <a:endParaRPr lang="en-US" sz="1350" dirty="0"/>
           </a:p>
         </p:txBody>
       </p:sp>
@@ -20268,8 +20268,8 @@
         </p:nvSpPr>
         <p:spPr>
           <a:xfrm>
-            <a:off x="3086100" y="3200400"/>
-            <a:ext cx="1554480" cy="457200"/>
+            <a:off x="3086100" y="3108960"/>
+            <a:ext cx="1554480" cy="548640"/>
           </a:xfrm>
           <a:prstGeom prst="rect">
             <a:avLst/>
@@ -20285,7 +20285,7 @@
               <a:buNone/>
             </a:pPr>
             <a:r>
-              <a:rPr lang="en-US" sz="1800" b="1" dirty="0">
+              <a:rPr lang="en-US" sz="1700" b="1" dirty="0">
                 <a:solidFill>
                   <a:srgbClr val="292524"/>
                 </a:solidFill>
@@ -20295,7 +20295,7 @@
               </a:rPr>
               <a:t>Easy to join</a:t>
             </a:r>
-            <a:endParaRPr lang="en-US" sz="1800" dirty="0"/>
+            <a:endParaRPr lang="en-US" sz="1700" dirty="0"/>
           </a:p>
         </p:txBody>
       </p:sp>
@@ -20324,7 +20324,7 @@
               <a:buNone/>
             </a:pPr>
             <a:r>
-              <a:rPr lang="en-US" sz="1400" dirty="0">
+              <a:rPr lang="en-US" sz="1350" dirty="0">
                 <a:solidFill>
                   <a:srgbClr val="78716C"/>
                 </a:solidFill>
@@ -20334,7 +20334,7 @@
               </a:rPr>
               <a:t>Join open activities instantly, or request a spot when the organizer approves joiners.</a:t>
             </a:r>
-            <a:endParaRPr lang="en-US" sz="1400" dirty="0"/>
+            <a:endParaRPr lang="en-US" sz="1350" dirty="0"/>
           </a:p>
         </p:txBody>
       </p:sp>
@@ -20419,8 +20419,8 @@
         </p:nvSpPr>
         <p:spPr>
           <a:xfrm>
-            <a:off x="5303520" y="3200400"/>
-            <a:ext cx="1554480" cy="457200"/>
+            <a:off x="5303520" y="3108960"/>
+            <a:ext cx="1554480" cy="548640"/>
           </a:xfrm>
           <a:prstGeom prst="rect">
             <a:avLst/>
@@ -20436,7 +20436,7 @@
               <a:buNone/>
             </a:pPr>
             <a:r>
-              <a:rPr lang="en-US" sz="1800" b="1" dirty="0">
+              <a:rPr lang="en-US" sz="1700" b="1" dirty="0">
                 <a:solidFill>
                   <a:srgbClr val="292524"/>
                 </a:solidFill>
@@ -20446,7 +20446,7 @@
               </a:rPr>
               <a:t>Easy to share</a:t>
             </a:r>
-            <a:endParaRPr lang="en-US" sz="1800" dirty="0"/>
+            <a:endParaRPr lang="en-US" sz="1700" dirty="0"/>
           </a:p>
         </p:txBody>
       </p:sp>
@@ -20475,7 +20475,7 @@
               <a:buNone/>
             </a:pPr>
             <a:r>
-              <a:rPr lang="en-US" sz="1400" dirty="0">
+              <a:rPr lang="en-US" sz="1350" dirty="0">
                 <a:solidFill>
                   <a:srgbClr val="78716C"/>
                 </a:solidFill>
@@ -20485,7 +20485,7 @@
               </a:rPr>
               <a:t>Invite link, WhatsApp, QR code and a ready-made flyer for every activity.</a:t>
             </a:r>
-            <a:endParaRPr lang="en-US" sz="1400" dirty="0"/>
+            <a:endParaRPr lang="en-US" sz="1350" dirty="0"/>
           </a:p>
         </p:txBody>
       </p:sp>
@@ -20570,8 +20570,8 @@
         </p:nvSpPr>
         <p:spPr>
           <a:xfrm>
-            <a:off x="7520940" y="3200400"/>
-            <a:ext cx="1554480" cy="457200"/>
+            <a:off x="7520940" y="3108960"/>
+            <a:ext cx="1554480" cy="548640"/>
           </a:xfrm>
           <a:prstGeom prst="rect">
             <a:avLst/>
@@ -20587,7 +20587,7 @@
               <a:buNone/>
             </a:pPr>
             <a:r>
-              <a:rPr lang="en-US" sz="1800" b="1" dirty="0">
+              <a:rPr lang="en-US" sz="1700" b="1" dirty="0">
                 <a:solidFill>
                   <a:srgbClr val="292524"/>
                 </a:solidFill>
@@ -20597,7 +20597,7 @@
               </a:rPr>
               <a:t>GPS stored</a:t>
             </a:r>
-            <a:endParaRPr lang="en-US" sz="1800" dirty="0"/>
+            <a:endParaRPr lang="en-US" sz="1700" dirty="0"/>
           </a:p>
         </p:txBody>
       </p:sp>
@@ -20626,7 +20626,7 @@
               <a:buNone/>
             </a:pPr>
             <a:r>
-              <a:rPr lang="en-US" sz="1400" dirty="0">
+              <a:rPr lang="en-US" sz="1350" dirty="0">
                 <a:solidFill>
                   <a:srgbClr val="78716C"/>
                 </a:solidFill>
@@ -20636,7 +20636,7 @@
               </a:rPr>
               <a:t>Your live location is used in the moment only and never saved to the database.</a:t>
             </a:r>
-            <a:endParaRPr lang="en-US" sz="1400" dirty="0"/>
+            <a:endParaRPr lang="en-US" sz="1350" dirty="0"/>
           </a:p>
         </p:txBody>
       </p:sp>
@@ -20721,8 +20721,8 @@
         </p:nvSpPr>
         <p:spPr>
           <a:xfrm>
-            <a:off x="9738360" y="3200400"/>
-            <a:ext cx="1554480" cy="457200"/>
+            <a:off x="9738360" y="3108960"/>
+            <a:ext cx="1554480" cy="548640"/>
           </a:xfrm>
           <a:prstGeom prst="rect">
             <a:avLst/>
@@ -20738,7 +20738,7 @@
               <a:buNone/>
             </a:pPr>
             <a:r>
-              <a:rPr lang="en-US" sz="1800" b="1" dirty="0">
+              <a:rPr lang="en-US" sz="1700" b="1" dirty="0">
                 <a:solidFill>
                   <a:srgbClr val="292524"/>
                 </a:solidFill>
@@ -20748,7 +20748,7 @@
               </a:rPr>
               <a:t>Bilingual</a:t>
             </a:r>
-            <a:endParaRPr lang="en-US" sz="1800" dirty="0"/>
+            <a:endParaRPr lang="en-US" sz="1700" dirty="0"/>
           </a:p>
         </p:txBody>
       </p:sp>
@@ -20777,7 +20777,7 @@
               <a:buNone/>
             </a:pPr>
             <a:r>
-              <a:rPr lang="en-US" sz="1400" dirty="0">
+              <a:rPr lang="en-US" sz="1350" dirty="0">
                 <a:solidFill>
                   <a:srgbClr val="78716C"/>
                 </a:solidFill>
@@ -20787,7 +20787,7 @@
               </a:rPr>
               <a:t>Every screen in English and Bahasa Indonesia, switchable at any time.</a:t>
             </a:r>
-            <a:endParaRPr lang="en-US" sz="1400" dirty="0"/>
+            <a:endParaRPr lang="en-US" sz="1350" dirty="0"/>
           </a:p>
         </p:txBody>
       </p:sp>
@@ -22014,7 +22014,7 @@
         <p:spPr>
           <a:xfrm>
             <a:off x="914400" y="3154680"/>
-            <a:ext cx="1463040" cy="457200"/>
+            <a:ext cx="1600200" cy="457200"/>
           </a:xfrm>
           <a:prstGeom prst="rect">
             <a:avLst/>
@@ -22030,7 +22030,7 @@
               <a:buNone/>
             </a:pPr>
             <a:r>
-              <a:rPr lang="en-US" sz="1800" b="1" dirty="0">
+              <a:rPr lang="en-US" sz="1600" b="1" dirty="0">
                 <a:solidFill>
                   <a:srgbClr val="292524"/>
                 </a:solidFill>
@@ -22040,7 +22040,7 @@
               </a:rPr>
               <a:t>Participant</a:t>
             </a:r>
-            <a:endParaRPr lang="en-US" sz="1800" dirty="0"/>
+            <a:endParaRPr lang="en-US" sz="1600" dirty="0"/>
           </a:p>
         </p:txBody>
       </p:sp>
@@ -22053,7 +22053,7 @@
         <p:spPr>
           <a:xfrm>
             <a:off x="914400" y="3657600"/>
-            <a:ext cx="1463040" cy="2011680"/>
+            <a:ext cx="1508760" cy="2011680"/>
           </a:xfrm>
           <a:prstGeom prst="rect">
             <a:avLst/>
@@ -22172,7 +22172,7 @@
         <p:spPr>
           <a:xfrm>
             <a:off x="3131820" y="3154680"/>
-            <a:ext cx="1463040" cy="457200"/>
+            <a:ext cx="1600200" cy="457200"/>
           </a:xfrm>
           <a:prstGeom prst="rect">
             <a:avLst/>
@@ -22188,7 +22188,7 @@
               <a:buNone/>
             </a:pPr>
             <a:r>
-              <a:rPr lang="en-US" sz="1800" b="1" dirty="0">
+              <a:rPr lang="en-US" sz="1600" b="1" dirty="0">
                 <a:solidFill>
                   <a:srgbClr val="292524"/>
                 </a:solidFill>
@@ -22198,7 +22198,7 @@
               </a:rPr>
               <a:t>Organizer</a:t>
             </a:r>
-            <a:endParaRPr lang="en-US" sz="1800" dirty="0"/>
+            <a:endParaRPr lang="en-US" sz="1600" dirty="0"/>
           </a:p>
         </p:txBody>
       </p:sp>
@@ -22211,7 +22211,7 @@
         <p:spPr>
           <a:xfrm>
             <a:off x="3131820" y="3657600"/>
-            <a:ext cx="1463040" cy="2011680"/>
+            <a:ext cx="1508760" cy="2011680"/>
           </a:xfrm>
           <a:prstGeom prst="rect">
             <a:avLst/>
@@ -22330,7 +22330,7 @@
         <p:spPr>
           <a:xfrm>
             <a:off x="5349240" y="3154680"/>
-            <a:ext cx="1463040" cy="457200"/>
+            <a:ext cx="1600200" cy="457200"/>
           </a:xfrm>
           <a:prstGeom prst="rect">
             <a:avLst/>
@@ -22346,7 +22346,7 @@
               <a:buNone/>
             </a:pPr>
             <a:r>
-              <a:rPr lang="en-US" sz="1800" b="1" dirty="0">
+              <a:rPr lang="en-US" sz="1600" b="1" dirty="0">
                 <a:solidFill>
                   <a:srgbClr val="292524"/>
                 </a:solidFill>
@@ -22356,7 +22356,7 @@
               </a:rPr>
               <a:t>Moderator</a:t>
             </a:r>
-            <a:endParaRPr lang="en-US" sz="1800" dirty="0"/>
+            <a:endParaRPr lang="en-US" sz="1600" dirty="0"/>
           </a:p>
         </p:txBody>
       </p:sp>
@@ -22369,7 +22369,7 @@
         <p:spPr>
           <a:xfrm>
             <a:off x="5349240" y="3657600"/>
-            <a:ext cx="1463040" cy="2011680"/>
+            <a:ext cx="1508760" cy="2011680"/>
           </a:xfrm>
           <a:prstGeom prst="rect">
             <a:avLst/>
@@ -22488,7 +22488,7 @@
         <p:spPr>
           <a:xfrm>
             <a:off x="7566660" y="3154680"/>
-            <a:ext cx="1463040" cy="457200"/>
+            <a:ext cx="1600200" cy="457200"/>
           </a:xfrm>
           <a:prstGeom prst="rect">
             <a:avLst/>
@@ -22504,7 +22504,7 @@
               <a:buNone/>
             </a:pPr>
             <a:r>
-              <a:rPr lang="en-US" sz="1800" b="1" dirty="0">
+              <a:rPr lang="en-US" sz="1600" b="1" dirty="0">
                 <a:solidFill>
                   <a:srgbClr val="292524"/>
                 </a:solidFill>
@@ -22514,7 +22514,7 @@
               </a:rPr>
               <a:t>Admin</a:t>
             </a:r>
-            <a:endParaRPr lang="en-US" sz="1800" dirty="0"/>
+            <a:endParaRPr lang="en-US" sz="1600" dirty="0"/>
           </a:p>
         </p:txBody>
       </p:sp>
@@ -22527,7 +22527,7 @@
         <p:spPr>
           <a:xfrm>
             <a:off x="7566660" y="3657600"/>
-            <a:ext cx="1463040" cy="2011680"/>
+            <a:ext cx="1508760" cy="2011680"/>
           </a:xfrm>
           <a:prstGeom prst="rect">
             <a:avLst/>
@@ -22646,7 +22646,7 @@
         <p:spPr>
           <a:xfrm>
             <a:off x="9784080" y="3154680"/>
-            <a:ext cx="1463040" cy="457200"/>
+            <a:ext cx="1600200" cy="457200"/>
           </a:xfrm>
           <a:prstGeom prst="rect">
             <a:avLst/>
@@ -22662,7 +22662,7 @@
               <a:buNone/>
             </a:pPr>
             <a:r>
-              <a:rPr lang="en-US" sz="1800" b="1" dirty="0">
+              <a:rPr lang="en-US" sz="1600" b="1" dirty="0">
                 <a:solidFill>
                   <a:srgbClr val="292524"/>
                 </a:solidFill>
@@ -22672,7 +22672,7 @@
               </a:rPr>
               <a:t>Super admin</a:t>
             </a:r>
-            <a:endParaRPr lang="en-US" sz="1800" dirty="0"/>
+            <a:endParaRPr lang="en-US" sz="1600" dirty="0"/>
           </a:p>
         </p:txBody>
       </p:sp>
@@ -22685,7 +22685,7 @@
         <p:spPr>
           <a:xfrm>
             <a:off x="9784080" y="3657600"/>
-            <a:ext cx="1463040" cy="2011680"/>
+            <a:ext cx="1508760" cy="2011680"/>
           </a:xfrm>
           <a:prstGeom prst="rect">
             <a:avLst/>
@@ -23055,7 +23055,7 @@
         <p:spPr>
           <a:xfrm>
             <a:off x="914400" y="3154680"/>
-            <a:ext cx="1417320" cy="411480"/>
+            <a:ext cx="1508760" cy="411480"/>
           </a:xfrm>
           <a:prstGeom prst="rect">
             <a:avLst/>
@@ -23094,7 +23094,7 @@
         <p:spPr>
           <a:xfrm>
             <a:off x="914400" y="3657600"/>
-            <a:ext cx="1417320" cy="1600200"/>
+            <a:ext cx="1463040" cy="1600200"/>
           </a:xfrm>
           <a:prstGeom prst="rect">
             <a:avLst/>
@@ -23276,7 +23276,7 @@
         <p:spPr>
           <a:xfrm>
             <a:off x="3154680" y="3154680"/>
-            <a:ext cx="1417320" cy="411480"/>
+            <a:ext cx="1508760" cy="411480"/>
           </a:xfrm>
           <a:prstGeom prst="rect">
             <a:avLst/>
@@ -23315,7 +23315,7 @@
         <p:spPr>
           <a:xfrm>
             <a:off x="3154680" y="3657600"/>
-            <a:ext cx="1417320" cy="1600200"/>
+            <a:ext cx="1463040" cy="1600200"/>
           </a:xfrm>
           <a:prstGeom prst="rect">
             <a:avLst/>
@@ -23497,7 +23497,7 @@
         <p:spPr>
           <a:xfrm>
             <a:off x="5394960" y="3154680"/>
-            <a:ext cx="1417320" cy="411480"/>
+            <a:ext cx="1508760" cy="411480"/>
           </a:xfrm>
           <a:prstGeom prst="rect">
             <a:avLst/>
@@ -23536,7 +23536,7 @@
         <p:spPr>
           <a:xfrm>
             <a:off x="5394960" y="3657600"/>
-            <a:ext cx="1417320" cy="1600200"/>
+            <a:ext cx="1463040" cy="1600200"/>
           </a:xfrm>
           <a:prstGeom prst="rect">
             <a:avLst/>
@@ -23718,7 +23718,7 @@
         <p:spPr>
           <a:xfrm>
             <a:off x="7635240" y="3154680"/>
-            <a:ext cx="1417320" cy="411480"/>
+            <a:ext cx="1508760" cy="411480"/>
           </a:xfrm>
           <a:prstGeom prst="rect">
             <a:avLst/>
@@ -23757,7 +23757,7 @@
         <p:spPr>
           <a:xfrm>
             <a:off x="7635240" y="3657600"/>
-            <a:ext cx="1417320" cy="1600200"/>
+            <a:ext cx="1463040" cy="1600200"/>
           </a:xfrm>
           <a:prstGeom prst="rect">
             <a:avLst/>
@@ -23939,7 +23939,7 @@
         <p:spPr>
           <a:xfrm>
             <a:off x="9875520" y="3154680"/>
-            <a:ext cx="1417320" cy="411480"/>
+            <a:ext cx="1508760" cy="411480"/>
           </a:xfrm>
           <a:prstGeom prst="rect">
             <a:avLst/>
@@ -23978,7 +23978,7 @@
         <p:spPr>
           <a:xfrm>
             <a:off x="9875520" y="3657600"/>
-            <a:ext cx="1417320" cy="1600200"/>
+            <a:ext cx="1463040" cy="1600200"/>
           </a:xfrm>
           <a:prstGeom prst="rect">
             <a:avLst/>

</xml_diff>